<commit_message>
Correct the agent's F1 row on the evaluation slide
The 0.857/0.760 on slide 7 matched no run record. bd576b8 made macro-F1
stricter -- it now averages over every tag in the truth or the prediction,
where it used to average over the truth alone -- so the old figure could not
be reproduced. A fresh run against Claude Haiku 4.5 with --few-shot 8 scores
0.745/0.555; both baseline rows were already right. Record in results/.
</commit_message>
<xml_diff>
--- a/Content Analysis Agent.pptx
+++ b/Content Analysis Agent.pptx
@@ -10095,7 +10095,7 @@
                 </a:solidFill>
                 <a:latin typeface="Consolas"/>
               </a:rPr>
-              <a:t>0.857</a:t>
+              <a:t>0.745</a:t>
             </a:r>
           </a:p>
         </p:txBody>
@@ -10137,7 +10137,7 @@
                 </a:solidFill>
                 <a:latin typeface="Consolas"/>
               </a:rPr>
-              <a:t>0.760</a:t>
+              <a:t>0.555</a:t>
             </a:r>
           </a:p>
         </p:txBody>

</xml_diff>